<commit_message>
Add SQL agent to slides, update README header and layout
- pptx: SQL Agent column added to all Agent Overview tables (slides 8/13/16), SQL label on cover, SQL bullet on TLDR slide
- README: name + LinkedIn + 2026 in header, property tables collapsed to <details> blocks, scoring scale sentence added

Co-Authored-By: Claude Sonnet 4.6 <noreply@anthropic.com>
</commit_message>
<xml_diff>
--- a/docs/bgg_agents_slides.pptx
+++ b/docs/bgg_agents_slides.pptx
@@ -10735,6 +10735,60 @@
           </a:p>
         </p:txBody>
       </p:sp>
+      <p:sp>
+        <p:nvSpPr>
+          <p:cNvPr id="83" name="TextBox 12"/>
+          <p:cNvSpPr/>
+          <p:nvPr/>
+        </p:nvSpPr>
+        <p:spPr>
+          <a:xfrm>
+            <a:off x="10652760" y="3512520"/>
+            <a:ext cx="1280160" cy="288720"/>
+          </a:xfrm>
+          <a:prstGeom prst="rect">
+            <a:avLst/>
+          </a:prstGeom>
+          <a:noFill/>
+          <a:ln w="0">
+            <a:noFill/>
+          </a:ln>
+        </p:spPr>
+        <p:style>
+          <a:lnRef idx="0"/>
+          <a:fillRef idx="0"/>
+          <a:effectRef idx="0"/>
+          <a:fontRef idx="minor"/>
+        </p:style>
+        <p:txBody>
+          <a:bodyPr lIns="90000" tIns="45000" rIns="90000" bIns="45000" anchor="t">
+            <a:spAutoFit/>
+          </a:bodyPr>
+          <a:p>
+            <a:pPr algn="ctr"/>
+            <a:r>
+              <a:rPr lang="en-US" sz="1300" b="0" u="none" strike="noStrike">
+                <a:solidFill>
+                  <a:srgbClr val="FFFFFF"/>
+                </a:solidFill>
+                <a:effectLst/>
+                <a:uFillTx/>
+                <a:latin typeface="Calibri"/>
+                <a:ea typeface="Calibri"/>
+              </a:rPr>
+              <a:t>SQL</a:t>
+            </a:r>
+            <a:endParaRPr lang="en-US" sz="1300" b="1" u="none" strike="noStrike">
+              <a:solidFill>
+                <a:srgbClr val="FFFFFF"/>
+              </a:solidFill>
+              <a:effectLst/>
+              <a:uFillTx/>
+              <a:latin typeface="Calibri"/>
+            </a:endParaRPr>
+          </a:p>
+        </p:txBody>
+      </p:sp>
     </p:spTree>
   </p:cSld>
   <mc:AlternateContent>
@@ -16764,7 +16818,7 @@
         <p:spPr>
           <a:xfrm>
             <a:off x="2130480" y="749880"/>
-            <a:ext cx="2465640" cy="435600"/>
+            <a:ext cx="1993392" cy="435600"/>
           </a:xfrm>
           <a:prstGeom prst="roundRect">
             <a:avLst>
@@ -16837,8 +16891,8 @@
         </p:nvSpPr>
         <p:spPr>
           <a:xfrm>
-            <a:off x="4626720" y="749880"/>
-            <a:ext cx="2465640" cy="435600"/>
+            <a:off x="4123944" y="749880"/>
+            <a:ext cx="1993392" cy="435600"/>
           </a:xfrm>
           <a:prstGeom prst="roundRect">
             <a:avLst>
@@ -16911,8 +16965,8 @@
         </p:nvSpPr>
         <p:spPr>
           <a:xfrm>
-            <a:off x="7123320" y="749880"/>
-            <a:ext cx="2465640" cy="435600"/>
+            <a:off x="6117336" y="749880"/>
+            <a:ext cx="1993392" cy="435600"/>
           </a:xfrm>
           <a:prstGeom prst="roundRect">
             <a:avLst>
@@ -16985,8 +17039,8 @@
         </p:nvSpPr>
         <p:spPr>
           <a:xfrm>
-            <a:off x="9619560" y="749880"/>
-            <a:ext cx="2465640" cy="435600"/>
+            <a:off x="8110727" y="749880"/>
+            <a:ext cx="1993392" cy="435600"/>
           </a:xfrm>
           <a:prstGeom prst="roundRect">
             <a:avLst>
@@ -17134,7 +17188,7 @@
         <p:spPr>
           <a:xfrm>
             <a:off x="2130480" y="1280160"/>
-            <a:ext cx="2465640" cy="655200"/>
+            <a:ext cx="1993392" cy="655200"/>
           </a:xfrm>
           <a:prstGeom prst="roundRect">
             <a:avLst>
@@ -17210,8 +17264,8 @@
         </p:nvSpPr>
         <p:spPr>
           <a:xfrm>
-            <a:off x="4626720" y="1280160"/>
-            <a:ext cx="2465640" cy="655200"/>
+            <a:off x="4123944" y="1280160"/>
+            <a:ext cx="1993392" cy="655200"/>
           </a:xfrm>
           <a:prstGeom prst="roundRect">
             <a:avLst>
@@ -17287,8 +17341,8 @@
         </p:nvSpPr>
         <p:spPr>
           <a:xfrm>
-            <a:off x="7123320" y="1280160"/>
-            <a:ext cx="2465640" cy="655200"/>
+            <a:off x="6117336" y="1280160"/>
+            <a:ext cx="1993392" cy="655200"/>
           </a:xfrm>
           <a:prstGeom prst="roundRect">
             <a:avLst>
@@ -17364,8 +17418,8 @@
         </p:nvSpPr>
         <p:spPr>
           <a:xfrm>
-            <a:off x="9619560" y="1280160"/>
-            <a:ext cx="2465640" cy="655200"/>
+            <a:off x="8110727" y="1280160"/>
+            <a:ext cx="1993392" cy="655200"/>
           </a:xfrm>
           <a:prstGeom prst="roundRect">
             <a:avLst>
@@ -17516,7 +17570,7 @@
         <p:spPr>
           <a:xfrm>
             <a:off x="2130480" y="2030040"/>
-            <a:ext cx="2465640" cy="655200"/>
+            <a:ext cx="1993392" cy="655200"/>
           </a:xfrm>
           <a:prstGeom prst="roundRect">
             <a:avLst>
@@ -17592,8 +17646,8 @@
         </p:nvSpPr>
         <p:spPr>
           <a:xfrm>
-            <a:off x="4626720" y="2030040"/>
-            <a:ext cx="2465640" cy="655200"/>
+            <a:off x="4123944" y="2030040"/>
+            <a:ext cx="1993392" cy="655200"/>
           </a:xfrm>
           <a:prstGeom prst="roundRect">
             <a:avLst>
@@ -17669,8 +17723,8 @@
         </p:nvSpPr>
         <p:spPr>
           <a:xfrm>
-            <a:off x="7123320" y="2030040"/>
-            <a:ext cx="2465640" cy="655200"/>
+            <a:off x="6117336" y="2030040"/>
+            <a:ext cx="1993392" cy="655200"/>
           </a:xfrm>
           <a:prstGeom prst="roundRect">
             <a:avLst>
@@ -17746,8 +17800,8 @@
         </p:nvSpPr>
         <p:spPr>
           <a:xfrm>
-            <a:off x="9619560" y="2030040"/>
-            <a:ext cx="2465640" cy="655200"/>
+            <a:off x="8110727" y="2030040"/>
+            <a:ext cx="1993392" cy="655200"/>
           </a:xfrm>
           <a:prstGeom prst="roundRect">
             <a:avLst>
@@ -17898,7 +17952,7 @@
         <p:spPr>
           <a:xfrm>
             <a:off x="2130480" y="2779920"/>
-            <a:ext cx="2465640" cy="655200"/>
+            <a:ext cx="1993392" cy="655200"/>
           </a:xfrm>
           <a:prstGeom prst="roundRect">
             <a:avLst>
@@ -17974,8 +18028,8 @@
         </p:nvSpPr>
         <p:spPr>
           <a:xfrm>
-            <a:off x="4626720" y="2779920"/>
-            <a:ext cx="2465640" cy="655200"/>
+            <a:off x="4123944" y="2779920"/>
+            <a:ext cx="1993392" cy="655200"/>
           </a:xfrm>
           <a:prstGeom prst="roundRect">
             <a:avLst>
@@ -18051,8 +18105,8 @@
         </p:nvSpPr>
         <p:spPr>
           <a:xfrm>
-            <a:off x="7123320" y="2779920"/>
-            <a:ext cx="2465640" cy="655200"/>
+            <a:off x="6117336" y="2779920"/>
+            <a:ext cx="1993392" cy="655200"/>
           </a:xfrm>
           <a:prstGeom prst="roundRect">
             <a:avLst>
@@ -18128,8 +18182,8 @@
         </p:nvSpPr>
         <p:spPr>
           <a:xfrm>
-            <a:off x="9619560" y="2779920"/>
-            <a:ext cx="2465640" cy="655200"/>
+            <a:off x="8110727" y="2779920"/>
+            <a:ext cx="1993392" cy="655200"/>
           </a:xfrm>
           <a:prstGeom prst="roundRect">
             <a:avLst>
@@ -18280,7 +18334,7 @@
         <p:spPr>
           <a:xfrm>
             <a:off x="2130480" y="3529440"/>
-            <a:ext cx="2465640" cy="655200"/>
+            <a:ext cx="1993392" cy="655200"/>
           </a:xfrm>
           <a:prstGeom prst="roundRect">
             <a:avLst>
@@ -18356,8 +18410,8 @@
         </p:nvSpPr>
         <p:spPr>
           <a:xfrm>
-            <a:off x="4626720" y="3529440"/>
-            <a:ext cx="2465640" cy="655200"/>
+            <a:off x="4123944" y="3529440"/>
+            <a:ext cx="1993392" cy="655200"/>
           </a:xfrm>
           <a:prstGeom prst="roundRect">
             <a:avLst>
@@ -18433,8 +18487,8 @@
         </p:nvSpPr>
         <p:spPr>
           <a:xfrm>
-            <a:off x="7123320" y="3529440"/>
-            <a:ext cx="2465640" cy="655200"/>
+            <a:off x="6117336" y="3529440"/>
+            <a:ext cx="1993392" cy="655200"/>
           </a:xfrm>
           <a:prstGeom prst="roundRect">
             <a:avLst>
@@ -18510,8 +18564,8 @@
         </p:nvSpPr>
         <p:spPr>
           <a:xfrm>
-            <a:off x="9619560" y="3529440"/>
-            <a:ext cx="2465640" cy="655200"/>
+            <a:off x="8110727" y="3529440"/>
+            <a:ext cx="1993392" cy="655200"/>
           </a:xfrm>
           <a:prstGeom prst="roundRect">
             <a:avLst>
@@ -18662,7 +18716,7 @@
         <p:spPr>
           <a:xfrm>
             <a:off x="2130480" y="4279320"/>
-            <a:ext cx="2465640" cy="655200"/>
+            <a:ext cx="1993392" cy="655200"/>
           </a:xfrm>
           <a:prstGeom prst="roundRect">
             <a:avLst>
@@ -18738,8 +18792,8 @@
         </p:nvSpPr>
         <p:spPr>
           <a:xfrm>
-            <a:off x="4626720" y="4279320"/>
-            <a:ext cx="2465640" cy="655200"/>
+            <a:off x="4123944" y="4279320"/>
+            <a:ext cx="1993392" cy="655200"/>
           </a:xfrm>
           <a:prstGeom prst="roundRect">
             <a:avLst>
@@ -18815,8 +18869,8 @@
         </p:nvSpPr>
         <p:spPr>
           <a:xfrm>
-            <a:off x="7123320" y="4279320"/>
-            <a:ext cx="2465640" cy="655200"/>
+            <a:off x="6117336" y="4279320"/>
+            <a:ext cx="1993392" cy="655200"/>
           </a:xfrm>
           <a:prstGeom prst="roundRect">
             <a:avLst>
@@ -18892,8 +18946,8 @@
         </p:nvSpPr>
         <p:spPr>
           <a:xfrm>
-            <a:off x="9619560" y="4279320"/>
-            <a:ext cx="2465640" cy="655200"/>
+            <a:off x="8110727" y="4279320"/>
+            <a:ext cx="1993392" cy="655200"/>
           </a:xfrm>
           <a:prstGeom prst="roundRect">
             <a:avLst>
@@ -19044,7 +19098,7 @@
         <p:spPr>
           <a:xfrm>
             <a:off x="2130480" y="5029200"/>
-            <a:ext cx="2465640" cy="655200"/>
+            <a:ext cx="1993392" cy="655200"/>
           </a:xfrm>
           <a:prstGeom prst="roundRect">
             <a:avLst>
@@ -19120,8 +19174,8 @@
         </p:nvSpPr>
         <p:spPr>
           <a:xfrm>
-            <a:off x="4626720" y="5029200"/>
-            <a:ext cx="2465640" cy="655200"/>
+            <a:off x="4123944" y="5029200"/>
+            <a:ext cx="1993392" cy="655200"/>
           </a:xfrm>
           <a:prstGeom prst="roundRect">
             <a:avLst>
@@ -19197,8 +19251,8 @@
         </p:nvSpPr>
         <p:spPr>
           <a:xfrm>
-            <a:off x="7123320" y="5029200"/>
-            <a:ext cx="2465640" cy="655200"/>
+            <a:off x="6117336" y="5029200"/>
+            <a:ext cx="1993392" cy="655200"/>
           </a:xfrm>
           <a:prstGeom prst="roundRect">
             <a:avLst>
@@ -19274,8 +19328,8 @@
         </p:nvSpPr>
         <p:spPr>
           <a:xfrm>
-            <a:off x="9619560" y="5029200"/>
-            <a:ext cx="2465640" cy="655200"/>
+            <a:off x="8110727" y="5029200"/>
+            <a:ext cx="1993392" cy="655200"/>
           </a:xfrm>
           <a:prstGeom prst="roundRect">
             <a:avLst>
@@ -19352,7 +19406,7 @@
         <p:spPr>
           <a:xfrm>
             <a:off x="2130480" y="4279320"/>
-            <a:ext cx="9982800" cy="1405080"/>
+            <a:ext cx="1993392" cy="1405080"/>
           </a:xfrm>
           <a:prstGeom prst="rect">
             <a:avLst/>
@@ -19378,6 +19432,542 @@
           </a:bodyPr>
           <a:p>
             <a:endParaRPr lang="en-US" sz="1800" b="0" u="none" strike="noStrike">
+              <a:solidFill>
+                <a:srgbClr val="000000"/>
+              </a:solidFill>
+              <a:effectLst/>
+              <a:uFillTx/>
+              <a:latin typeface="Arial"/>
+            </a:endParaRPr>
+          </a:p>
+        </p:txBody>
+      </p:sp>
+      <p:sp>
+        <p:nvSpPr>
+          <p:cNvPr id="300" name="Rounded Rectangle 47"/>
+          <p:cNvSpPr/>
+          <p:nvPr/>
+        </p:nvSpPr>
+        <p:spPr>
+          <a:xfrm>
+            <a:off x="10104120" y="749880"/>
+            <a:ext cx="1993392" cy="435600"/>
+          </a:xfrm>
+          <a:prstGeom prst="roundRect">
+            <a:avLst>
+              <a:gd name="adj" fmla="val 16667"/>
+            </a:avLst>
+          </a:prstGeom>
+          <a:solidFill>
+            <a:srgbClr val="C0392B"/>
+          </a:solidFill>
+          <a:ln>
+            <a:noFill/>
+          </a:ln>
+          <a:effectLst>
+            <a:outerShdw blurRad="39960" dir="5400000" dist="23040" rotWithShape="0">
+              <a:srgbClr val="000000">
+                <a:alpha val="35000"/>
+              </a:srgbClr>
+            </a:outerShdw>
+          </a:effectLst>
+        </p:spPr>
+        <p:style>
+          <a:lnRef idx="1">
+            <a:schemeClr val="accent1"/>
+          </a:lnRef>
+          <a:fillRef idx="3">
+            <a:schemeClr val="accent1"/>
+          </a:fillRef>
+          <a:effectRef idx="2">
+            <a:schemeClr val="accent1"/>
+          </a:effectRef>
+          <a:fontRef idx="minor"/>
+        </p:style>
+        <p:txBody>
+          <a:bodyPr lIns="73080" tIns="54720" rIns="73080" bIns="54720" anchor="ctr">
+            <a:noAutofit/>
+          </a:bodyPr>
+          <a:p>
+            <a:pPr algn="ctr" defTabSz="457200">
+              <a:lnSpc>
+                <a:spcPct val="100000"/>
+              </a:lnSpc>
+            </a:pPr>
+            <a:r>
+              <a:rPr lang="en-US" sz="1500" b="1" u="none" strike="noStrike">
+                <a:solidFill>
+                  <a:srgbClr val="FFFFFF"/>
+                </a:solidFill>
+                <a:effectLst/>
+                <a:uFillTx/>
+                <a:latin typeface="Calibri"/>
+              </a:rPr>
+              <a:t>SQL Agent</a:t>
+            </a:r>
+            <a:endParaRPr lang="en-US" sz="1500" b="0" u="none" strike="noStrike">
+              <a:solidFill>
+                <a:srgbClr val="FFFFFF"/>
+              </a:solidFill>
+              <a:effectLst/>
+              <a:uFillTx/>
+              <a:latin typeface="Arial"/>
+            </a:endParaRPr>
+          </a:p>
+        </p:txBody>
+      </p:sp>
+      <p:sp>
+        <p:nvSpPr>
+          <p:cNvPr id="305" name="Rounded Rectangle 58"/>
+          <p:cNvSpPr/>
+          <p:nvPr/>
+        </p:nvSpPr>
+        <p:spPr>
+          <a:xfrm>
+            <a:off x="10104120" y="1280160"/>
+            <a:ext cx="1993392" cy="655200"/>
+          </a:xfrm>
+          <a:prstGeom prst="roundRect">
+            <a:avLst>
+              <a:gd name="adj" fmla="val 16667"/>
+            </a:avLst>
+          </a:prstGeom>
+          <a:solidFill>
+            <a:srgbClr val="E8ECF0"/>
+          </a:solidFill>
+          <a:ln w="12700">
+            <a:solidFill>
+              <a:srgbClr val="909AA8"/>
+            </a:solidFill>
+            <a:round/>
+          </a:ln>
+          <a:effectLst>
+            <a:outerShdw blurRad="39960" dir="5400000" dist="23040" rotWithShape="0">
+              <a:srgbClr val="000000">
+                <a:alpha val="35000"/>
+              </a:srgbClr>
+            </a:outerShdw>
+          </a:effectLst>
+        </p:spPr>
+        <p:style>
+          <a:lnRef idx="1">
+            <a:schemeClr val="accent1"/>
+          </a:lnRef>
+          <a:fillRef idx="3">
+            <a:schemeClr val="accent1"/>
+          </a:fillRef>
+          <a:effectRef idx="2">
+            <a:schemeClr val="accent1"/>
+          </a:effectRef>
+          <a:fontRef idx="minor"/>
+        </p:style>
+        <p:txBody>
+          <a:bodyPr lIns="73080" tIns="54720" rIns="73080" bIns="54720" anchor="ctr">
+            <a:noAutofit/>
+          </a:bodyPr>
+          <a:p>
+            <a:pPr algn="ctr" defTabSz="457200">
+              <a:lnSpc>
+                <a:spcPct val="100000"/>
+              </a:lnSpc>
+            </a:pPr>
+            <a:r>
+              <a:rPr lang="en-US" sz="1200" b="0" u="none" strike="noStrike">
+                <a:solidFill>
+                  <a:srgbClr val="1A1A2E"/>
+                </a:solidFill>
+                <a:effectLst/>
+                <a:uFillTx/>
+                <a:latin typeface="Calibri"/>
+              </a:rPr>
+              <a:t>Claude Sonnet 4.6</a:t>
+            </a:r>
+            <a:endParaRPr lang="en-US" sz="1200" b="0" u="none" strike="noStrike">
+              <a:solidFill>
+                <a:srgbClr val="000000"/>
+              </a:solidFill>
+              <a:effectLst/>
+              <a:uFillTx/>
+              <a:latin typeface="Arial"/>
+            </a:endParaRPr>
+          </a:p>
+        </p:txBody>
+      </p:sp>
+      <p:sp>
+        <p:nvSpPr>
+          <p:cNvPr id="310" name="Rounded Rectangle 68"/>
+          <p:cNvSpPr/>
+          <p:nvPr/>
+        </p:nvSpPr>
+        <p:spPr>
+          <a:xfrm>
+            <a:off x="10104120" y="2030040"/>
+            <a:ext cx="1993392" cy="655200"/>
+          </a:xfrm>
+          <a:prstGeom prst="roundRect">
+            <a:avLst>
+              <a:gd name="adj" fmla="val 16667"/>
+            </a:avLst>
+          </a:prstGeom>
+          <a:solidFill>
+            <a:srgbClr val="FFFFFF"/>
+          </a:solidFill>
+          <a:ln w="12700">
+            <a:solidFill>
+              <a:srgbClr val="909AA8"/>
+            </a:solidFill>
+            <a:round/>
+          </a:ln>
+          <a:effectLst>
+            <a:outerShdw blurRad="39960" dir="5400000" dist="23040" rotWithShape="0">
+              <a:srgbClr val="000000">
+                <a:alpha val="35000"/>
+              </a:srgbClr>
+            </a:outerShdw>
+          </a:effectLst>
+        </p:spPr>
+        <p:style>
+          <a:lnRef idx="1">
+            <a:schemeClr val="accent1"/>
+          </a:lnRef>
+          <a:fillRef idx="3">
+            <a:schemeClr val="accent1"/>
+          </a:fillRef>
+          <a:effectRef idx="2">
+            <a:schemeClr val="accent1"/>
+          </a:effectRef>
+          <a:fontRef idx="minor"/>
+        </p:style>
+        <p:txBody>
+          <a:bodyPr lIns="73080" tIns="54720" rIns="73080" bIns="54720" anchor="ctr">
+            <a:noAutofit/>
+          </a:bodyPr>
+          <a:p>
+            <a:pPr algn="ctr" defTabSz="457200">
+              <a:lnSpc>
+                <a:spcPct val="100000"/>
+              </a:lnSpc>
+            </a:pPr>
+            <a:r>
+              <a:rPr lang="en-US" sz="1200" b="0" u="none" strike="noStrike">
+                <a:solidFill>
+                  <a:srgbClr val="1A1A2E"/>
+                </a:solidFill>
+                <a:effectLst/>
+                <a:uFillTx/>
+                <a:latin typeface="Calibri"/>
+              </a:rPr>
+              <a:t>33k (SQLite)</a:t>
+            </a:r>
+            <a:endParaRPr lang="en-US" sz="1200" b="0" u="none" strike="noStrike">
+              <a:solidFill>
+                <a:srgbClr val="000000"/>
+              </a:solidFill>
+              <a:effectLst/>
+              <a:uFillTx/>
+              <a:latin typeface="Arial"/>
+            </a:endParaRPr>
+          </a:p>
+        </p:txBody>
+      </p:sp>
+      <p:sp>
+        <p:nvSpPr>
+          <p:cNvPr id="315" name="Rounded Rectangle 112"/>
+          <p:cNvSpPr/>
+          <p:nvPr/>
+        </p:nvSpPr>
+        <p:spPr>
+          <a:xfrm>
+            <a:off x="10104120" y="2779920"/>
+            <a:ext cx="1993392" cy="655200"/>
+          </a:xfrm>
+          <a:prstGeom prst="roundRect">
+            <a:avLst>
+              <a:gd name="adj" fmla="val 16667"/>
+            </a:avLst>
+          </a:prstGeom>
+          <a:solidFill>
+            <a:srgbClr val="E8ECF0"/>
+          </a:solidFill>
+          <a:ln w="12700">
+            <a:solidFill>
+              <a:srgbClr val="909AA8"/>
+            </a:solidFill>
+            <a:round/>
+          </a:ln>
+          <a:effectLst>
+            <a:outerShdw blurRad="39960" dir="5400000" dist="23040" rotWithShape="0">
+              <a:srgbClr val="000000">
+                <a:alpha val="35000"/>
+              </a:srgbClr>
+            </a:outerShdw>
+          </a:effectLst>
+        </p:spPr>
+        <p:style>
+          <a:lnRef idx="1">
+            <a:schemeClr val="accent1"/>
+          </a:lnRef>
+          <a:fillRef idx="3">
+            <a:schemeClr val="accent1"/>
+          </a:fillRef>
+          <a:effectRef idx="2">
+            <a:schemeClr val="accent1"/>
+          </a:effectRef>
+          <a:fontRef idx="minor"/>
+        </p:style>
+        <p:txBody>
+          <a:bodyPr lIns="73080" tIns="54720" rIns="73080" bIns="54720" anchor="ctr">
+            <a:noAutofit/>
+          </a:bodyPr>
+          <a:p>
+            <a:pPr algn="ctr" defTabSz="457200">
+              <a:lnSpc>
+                <a:spcPct val="100000"/>
+              </a:lnSpc>
+            </a:pPr>
+            <a:r>
+              <a:rPr lang="en-US" sz="1200" b="0" u="none" strike="noStrike">
+                <a:solidFill>
+                  <a:srgbClr val="1A1A2E"/>
+                </a:solidFill>
+                <a:effectLst/>
+                <a:uFillTx/>
+                <a:latin typeface="Calibri"/>
+              </a:rPr>
+              <a:t>NL &gt; SQL &gt; SQLite</a:t>
+            </a:r>
+            <a:endParaRPr lang="en-US" sz="1200" b="0" u="none" strike="noStrike">
+              <a:solidFill>
+                <a:srgbClr val="000000"/>
+              </a:solidFill>
+              <a:effectLst/>
+              <a:uFillTx/>
+              <a:latin typeface="Arial"/>
+            </a:endParaRPr>
+          </a:p>
+        </p:txBody>
+      </p:sp>
+      <p:sp>
+        <p:nvSpPr>
+          <p:cNvPr id="320" name="Rounded Rectangle 117"/>
+          <p:cNvSpPr/>
+          <p:nvPr/>
+        </p:nvSpPr>
+        <p:spPr>
+          <a:xfrm>
+            <a:off x="10104120" y="3529440"/>
+            <a:ext cx="1993392" cy="655200"/>
+          </a:xfrm>
+          <a:prstGeom prst="roundRect">
+            <a:avLst>
+              <a:gd name="adj" fmla="val 16667"/>
+            </a:avLst>
+          </a:prstGeom>
+          <a:solidFill>
+            <a:srgbClr val="FFFFFF"/>
+          </a:solidFill>
+          <a:ln w="12700">
+            <a:solidFill>
+              <a:srgbClr val="909AA8"/>
+            </a:solidFill>
+            <a:round/>
+          </a:ln>
+          <a:effectLst>
+            <a:outerShdw blurRad="39960" dir="5400000" dist="23040" rotWithShape="0">
+              <a:srgbClr val="000000">
+                <a:alpha val="35000"/>
+              </a:srgbClr>
+            </a:outerShdw>
+          </a:effectLst>
+        </p:spPr>
+        <p:style>
+          <a:lnRef idx="1">
+            <a:schemeClr val="accent1"/>
+          </a:lnRef>
+          <a:fillRef idx="3">
+            <a:schemeClr val="accent1"/>
+          </a:fillRef>
+          <a:effectRef idx="2">
+            <a:schemeClr val="accent1"/>
+          </a:effectRef>
+          <a:fontRef idx="minor"/>
+        </p:style>
+        <p:txBody>
+          <a:bodyPr lIns="73080" tIns="54720" rIns="73080" bIns="54720" anchor="ctr">
+            <a:noAutofit/>
+          </a:bodyPr>
+          <a:p>
+            <a:pPr algn="ctr" defTabSz="457200">
+              <a:lnSpc>
+                <a:spcPct val="100000"/>
+              </a:lnSpc>
+            </a:pPr>
+            <a:r>
+              <a:rPr lang="en-US" sz="1200" b="0" u="none" strike="noStrike">
+                <a:solidFill>
+                  <a:srgbClr val="1A1A2E"/>
+                </a:solidFill>
+                <a:effectLst/>
+                <a:uFillTx/>
+                <a:latin typeface="Calibri"/>
+              </a:rPr>
+              <a:t>~$0.30</a:t>
+            </a:r>
+            <a:endParaRPr lang="en-US" sz="1200" b="0" u="none" strike="noStrike">
+              <a:solidFill>
+                <a:srgbClr val="000000"/>
+              </a:solidFill>
+              <a:effectLst/>
+              <a:uFillTx/>
+              <a:latin typeface="Arial"/>
+            </a:endParaRPr>
+          </a:p>
+        </p:txBody>
+      </p:sp>
+      <p:sp>
+        <p:nvSpPr>
+          <p:cNvPr id="325" name="Rounded Rectangle 122"/>
+          <p:cNvSpPr/>
+          <p:nvPr/>
+        </p:nvSpPr>
+        <p:spPr>
+          <a:xfrm>
+            <a:off x="10104120" y="4279320"/>
+            <a:ext cx="1993392" cy="655200"/>
+          </a:xfrm>
+          <a:prstGeom prst="roundRect">
+            <a:avLst>
+              <a:gd name="adj" fmla="val 16667"/>
+            </a:avLst>
+          </a:prstGeom>
+          <a:solidFill>
+            <a:srgbClr val="E8ECF0"/>
+          </a:solidFill>
+          <a:ln w="12700">
+            <a:solidFill>
+              <a:srgbClr val="909AA8"/>
+            </a:solidFill>
+            <a:round/>
+          </a:ln>
+          <a:effectLst>
+            <a:outerShdw blurRad="39960" dir="5400000" dist="23040" rotWithShape="0">
+              <a:srgbClr val="000000">
+                <a:alpha val="35000"/>
+              </a:srgbClr>
+            </a:outerShdw>
+          </a:effectLst>
+        </p:spPr>
+        <p:style>
+          <a:lnRef idx="1">
+            <a:schemeClr val="accent1"/>
+          </a:lnRef>
+          <a:fillRef idx="3">
+            <a:schemeClr val="accent1"/>
+          </a:fillRef>
+          <a:effectRef idx="2">
+            <a:schemeClr val="accent1"/>
+          </a:effectRef>
+          <a:fontRef idx="minor"/>
+        </p:style>
+        <p:txBody>
+          <a:bodyPr lIns="73080" tIns="54720" rIns="73080" bIns="54720" anchor="ctr">
+            <a:noAutofit/>
+          </a:bodyPr>
+          <a:p>
+            <a:pPr algn="ctr" defTabSz="457200">
+              <a:lnSpc>
+                <a:spcPct val="100000"/>
+              </a:lnSpc>
+            </a:pPr>
+            <a:r>
+              <a:rPr lang="en-US" sz="1200" b="0" u="none" strike="noStrike">
+                <a:solidFill>
+                  <a:srgbClr val="1A1A2E"/>
+                </a:solidFill>
+                <a:effectLst/>
+                <a:uFillTx/>
+                <a:latin typeface="Calibri"/>
+              </a:rPr>
+              <a:t>9.5/10†</a:t>
+            </a:r>
+            <a:endParaRPr lang="en-US" sz="1200" b="0" u="none" strike="noStrike">
+              <a:solidFill>
+                <a:srgbClr val="000000"/>
+              </a:solidFill>
+              <a:effectLst/>
+              <a:uFillTx/>
+              <a:latin typeface="Arial"/>
+            </a:endParaRPr>
+          </a:p>
+        </p:txBody>
+      </p:sp>
+      <p:sp>
+        <p:nvSpPr>
+          <p:cNvPr id="330" name="Rounded Rectangle 127"/>
+          <p:cNvSpPr/>
+          <p:nvPr/>
+        </p:nvSpPr>
+        <p:spPr>
+          <a:xfrm>
+            <a:off x="10104120" y="5029200"/>
+            <a:ext cx="1993392" cy="655200"/>
+          </a:xfrm>
+          <a:prstGeom prst="roundRect">
+            <a:avLst>
+              <a:gd name="adj" fmla="val 16667"/>
+            </a:avLst>
+          </a:prstGeom>
+          <a:solidFill>
+            <a:srgbClr val="FFFFFF"/>
+          </a:solidFill>
+          <a:ln w="12700">
+            <a:solidFill>
+              <a:srgbClr val="909AA8"/>
+            </a:solidFill>
+            <a:round/>
+          </a:ln>
+          <a:effectLst>
+            <a:outerShdw blurRad="39960" dir="5400000" dist="23040" rotWithShape="0">
+              <a:srgbClr val="000000">
+                <a:alpha val="35000"/>
+              </a:srgbClr>
+            </a:outerShdw>
+          </a:effectLst>
+        </p:spPr>
+        <p:style>
+          <a:lnRef idx="1">
+            <a:schemeClr val="accent1"/>
+          </a:lnRef>
+          <a:fillRef idx="3">
+            <a:schemeClr val="accent1"/>
+          </a:fillRef>
+          <a:effectRef idx="2">
+            <a:schemeClr val="accent1"/>
+          </a:effectRef>
+          <a:fontRef idx="minor"/>
+        </p:style>
+        <p:txBody>
+          <a:bodyPr lIns="73080" tIns="54720" rIns="73080" bIns="54720" anchor="ctr">
+            <a:noAutofit/>
+          </a:bodyPr>
+          <a:p>
+            <a:pPr algn="ctr" defTabSz="457200">
+              <a:lnSpc>
+                <a:spcPct val="100000"/>
+              </a:lnSpc>
+            </a:pPr>
+            <a:r>
+              <a:rPr lang="en-US" sz="1200" b="0" u="none" strike="noStrike">
+                <a:solidFill>
+                  <a:srgbClr val="1A1A2E"/>
+                </a:solidFill>
+                <a:effectLst/>
+                <a:uFillTx/>
+                <a:latin typeface="Calibri"/>
+              </a:rPr>
+              <a:t>Dev-familiar</a:t>
+            </a:r>
+            <a:endParaRPr lang="en-US" sz="1200" b="0" u="none" strike="noStrike">
               <a:solidFill>
                 <a:srgbClr val="000000"/>
               </a:solidFill>
@@ -28936,7 +29526,7 @@
         <p:spPr>
           <a:xfrm>
             <a:off x="2130480" y="749880"/>
-            <a:ext cx="2465640" cy="435600"/>
+            <a:ext cx="1993392" cy="435600"/>
           </a:xfrm>
           <a:prstGeom prst="roundRect">
             <a:avLst>
@@ -29009,8 +29599,8 @@
         </p:nvSpPr>
         <p:spPr>
           <a:xfrm>
-            <a:off x="4626720" y="749880"/>
-            <a:ext cx="2465640" cy="435600"/>
+            <a:off x="4123944" y="749880"/>
+            <a:ext cx="1993392" cy="435600"/>
           </a:xfrm>
           <a:prstGeom prst="roundRect">
             <a:avLst>
@@ -29083,8 +29673,8 @@
         </p:nvSpPr>
         <p:spPr>
           <a:xfrm>
-            <a:off x="9619560" y="749880"/>
-            <a:ext cx="2465640" cy="435600"/>
+            <a:off x="8110727" y="749880"/>
+            <a:ext cx="1993392" cy="435600"/>
           </a:xfrm>
           <a:prstGeom prst="roundRect">
             <a:avLst>
@@ -29232,7 +29822,7 @@
         <p:spPr>
           <a:xfrm>
             <a:off x="2130480" y="1280160"/>
-            <a:ext cx="2465640" cy="655200"/>
+            <a:ext cx="1993392" cy="655200"/>
           </a:xfrm>
           <a:prstGeom prst="roundRect">
             <a:avLst>
@@ -29308,8 +29898,8 @@
         </p:nvSpPr>
         <p:spPr>
           <a:xfrm>
-            <a:off x="4626720" y="1280160"/>
-            <a:ext cx="2465640" cy="655200"/>
+            <a:off x="4123944" y="1280160"/>
+            <a:ext cx="1993392" cy="655200"/>
           </a:xfrm>
           <a:prstGeom prst="roundRect">
             <a:avLst>
@@ -29385,8 +29975,8 @@
         </p:nvSpPr>
         <p:spPr>
           <a:xfrm>
-            <a:off x="7123320" y="1280160"/>
-            <a:ext cx="2465640" cy="655200"/>
+            <a:off x="6117336" y="1280160"/>
+            <a:ext cx="1993392" cy="655200"/>
           </a:xfrm>
           <a:prstGeom prst="roundRect">
             <a:avLst>
@@ -29462,8 +30052,8 @@
         </p:nvSpPr>
         <p:spPr>
           <a:xfrm>
-            <a:off x="9619560" y="1280160"/>
-            <a:ext cx="2465640" cy="655200"/>
+            <a:off x="8110727" y="1280160"/>
+            <a:ext cx="1993392" cy="655200"/>
           </a:xfrm>
           <a:prstGeom prst="roundRect">
             <a:avLst>
@@ -29614,7 +30204,7 @@
         <p:spPr>
           <a:xfrm>
             <a:off x="2130480" y="2030040"/>
-            <a:ext cx="2465640" cy="655200"/>
+            <a:ext cx="1993392" cy="655200"/>
           </a:xfrm>
           <a:prstGeom prst="roundRect">
             <a:avLst>
@@ -29690,8 +30280,8 @@
         </p:nvSpPr>
         <p:spPr>
           <a:xfrm>
-            <a:off x="4626720" y="2030040"/>
-            <a:ext cx="2465640" cy="655200"/>
+            <a:off x="4123944" y="2030040"/>
+            <a:ext cx="1993392" cy="655200"/>
           </a:xfrm>
           <a:prstGeom prst="roundRect">
             <a:avLst>
@@ -29767,8 +30357,8 @@
         </p:nvSpPr>
         <p:spPr>
           <a:xfrm>
-            <a:off x="7123320" y="2030040"/>
-            <a:ext cx="2465640" cy="655200"/>
+            <a:off x="6117336" y="2030040"/>
+            <a:ext cx="1993392" cy="655200"/>
           </a:xfrm>
           <a:prstGeom prst="roundRect">
             <a:avLst>
@@ -29844,8 +30434,8 @@
         </p:nvSpPr>
         <p:spPr>
           <a:xfrm>
-            <a:off x="9619560" y="2030040"/>
-            <a:ext cx="2465640" cy="655200"/>
+            <a:off x="8110727" y="2030040"/>
+            <a:ext cx="1993392" cy="655200"/>
           </a:xfrm>
           <a:prstGeom prst="roundRect">
             <a:avLst>
@@ -29996,7 +30586,7 @@
         <p:spPr>
           <a:xfrm>
             <a:off x="2130480" y="2779920"/>
-            <a:ext cx="2465640" cy="655200"/>
+            <a:ext cx="1993392" cy="655200"/>
           </a:xfrm>
           <a:prstGeom prst="roundRect">
             <a:avLst>
@@ -30072,8 +30662,8 @@
         </p:nvSpPr>
         <p:spPr>
           <a:xfrm>
-            <a:off x="4626720" y="2779920"/>
-            <a:ext cx="2465640" cy="655200"/>
+            <a:off x="4123944" y="2779920"/>
+            <a:ext cx="1993392" cy="655200"/>
           </a:xfrm>
           <a:prstGeom prst="roundRect">
             <a:avLst>
@@ -30149,8 +30739,8 @@
         </p:nvSpPr>
         <p:spPr>
           <a:xfrm>
-            <a:off x="7123320" y="2779920"/>
-            <a:ext cx="2465640" cy="655200"/>
+            <a:off x="6117336" y="2779920"/>
+            <a:ext cx="1993392" cy="655200"/>
           </a:xfrm>
           <a:prstGeom prst="roundRect">
             <a:avLst>
@@ -30226,8 +30816,8 @@
         </p:nvSpPr>
         <p:spPr>
           <a:xfrm>
-            <a:off x="9619560" y="2779920"/>
-            <a:ext cx="2465640" cy="655200"/>
+            <a:off x="8110727" y="2779920"/>
+            <a:ext cx="1993392" cy="655200"/>
           </a:xfrm>
           <a:prstGeom prst="roundRect">
             <a:avLst>
@@ -30378,7 +30968,7 @@
         <p:spPr>
           <a:xfrm>
             <a:off x="2130480" y="3529440"/>
-            <a:ext cx="2465640" cy="655200"/>
+            <a:ext cx="1993392" cy="655200"/>
           </a:xfrm>
           <a:prstGeom prst="roundRect">
             <a:avLst>
@@ -30454,8 +31044,8 @@
         </p:nvSpPr>
         <p:spPr>
           <a:xfrm>
-            <a:off x="4626720" y="3529440"/>
-            <a:ext cx="2465640" cy="655200"/>
+            <a:off x="4123944" y="3529440"/>
+            <a:ext cx="1993392" cy="655200"/>
           </a:xfrm>
           <a:prstGeom prst="roundRect">
             <a:avLst>
@@ -30531,8 +31121,8 @@
         </p:nvSpPr>
         <p:spPr>
           <a:xfrm>
-            <a:off x="7123320" y="3529440"/>
-            <a:ext cx="2465640" cy="655200"/>
+            <a:off x="6117336" y="3529440"/>
+            <a:ext cx="1993392" cy="655200"/>
           </a:xfrm>
           <a:prstGeom prst="roundRect">
             <a:avLst>
@@ -30608,8 +31198,8 @@
         </p:nvSpPr>
         <p:spPr>
           <a:xfrm>
-            <a:off x="9619560" y="3529440"/>
-            <a:ext cx="2465640" cy="655200"/>
+            <a:off x="8110727" y="3529440"/>
+            <a:ext cx="1993392" cy="655200"/>
           </a:xfrm>
           <a:prstGeom prst="roundRect">
             <a:avLst>
@@ -30760,7 +31350,7 @@
         <p:spPr>
           <a:xfrm>
             <a:off x="2130480" y="4279320"/>
-            <a:ext cx="2465640" cy="655200"/>
+            <a:ext cx="1993392" cy="655200"/>
           </a:xfrm>
           <a:prstGeom prst="roundRect">
             <a:avLst>
@@ -30836,8 +31426,8 @@
         </p:nvSpPr>
         <p:spPr>
           <a:xfrm>
-            <a:off x="4626720" y="4279320"/>
-            <a:ext cx="2465640" cy="655200"/>
+            <a:off x="4123944" y="4279320"/>
+            <a:ext cx="1993392" cy="655200"/>
           </a:xfrm>
           <a:prstGeom prst="roundRect">
             <a:avLst>
@@ -30913,8 +31503,8 @@
         </p:nvSpPr>
         <p:spPr>
           <a:xfrm>
-            <a:off x="7123320" y="4279320"/>
-            <a:ext cx="2465640" cy="655200"/>
+            <a:off x="6117336" y="4279320"/>
+            <a:ext cx="1993392" cy="655200"/>
           </a:xfrm>
           <a:prstGeom prst="roundRect">
             <a:avLst>
@@ -30990,8 +31580,8 @@
         </p:nvSpPr>
         <p:spPr>
           <a:xfrm>
-            <a:off x="9619560" y="4279320"/>
-            <a:ext cx="2465640" cy="655200"/>
+            <a:off x="8110727" y="4279320"/>
+            <a:ext cx="1993392" cy="655200"/>
           </a:xfrm>
           <a:prstGeom prst="roundRect">
             <a:avLst>
@@ -31142,7 +31732,7 @@
         <p:spPr>
           <a:xfrm>
             <a:off x="2130480" y="5029200"/>
-            <a:ext cx="2465640" cy="655200"/>
+            <a:ext cx="1993392" cy="655200"/>
           </a:xfrm>
           <a:prstGeom prst="roundRect">
             <a:avLst>
@@ -31218,8 +31808,8 @@
         </p:nvSpPr>
         <p:spPr>
           <a:xfrm>
-            <a:off x="4626720" y="5029200"/>
-            <a:ext cx="2465640" cy="655200"/>
+            <a:off x="4123944" y="5029200"/>
+            <a:ext cx="1993392" cy="655200"/>
           </a:xfrm>
           <a:prstGeom prst="roundRect">
             <a:avLst>
@@ -31295,8 +31885,8 @@
         </p:nvSpPr>
         <p:spPr>
           <a:xfrm>
-            <a:off x="7123320" y="5029200"/>
-            <a:ext cx="2465640" cy="655200"/>
+            <a:off x="6117336" y="5029200"/>
+            <a:ext cx="1993392" cy="655200"/>
           </a:xfrm>
           <a:prstGeom prst="roundRect">
             <a:avLst>
@@ -31372,8 +31962,8 @@
         </p:nvSpPr>
         <p:spPr>
           <a:xfrm>
-            <a:off x="9619560" y="5029200"/>
-            <a:ext cx="2465640" cy="655200"/>
+            <a:off x="8110727" y="5029200"/>
+            <a:ext cx="1993392" cy="655200"/>
           </a:xfrm>
           <a:prstGeom prst="roundRect">
             <a:avLst>
@@ -31449,8 +32039,8 @@
         </p:nvSpPr>
         <p:spPr>
           <a:xfrm>
-            <a:off x="7123680" y="749880"/>
-            <a:ext cx="2465640" cy="435600"/>
+            <a:off x="6117336" y="749880"/>
+            <a:ext cx="1993392" cy="435600"/>
           </a:xfrm>
           <a:prstGeom prst="roundRect">
             <a:avLst>
@@ -31507,6 +32097,542 @@
             <a:endParaRPr lang="en-US" sz="1500" b="0" u="none" strike="noStrike">
               <a:solidFill>
                 <a:srgbClr val="FFFFFF"/>
+              </a:solidFill>
+              <a:effectLst/>
+              <a:uFillTx/>
+              <a:latin typeface="Arial"/>
+            </a:endParaRPr>
+          </a:p>
+        </p:txBody>
+      </p:sp>
+      <p:sp>
+        <p:nvSpPr>
+          <p:cNvPr id="466" name="Rounded Rectangle 78"/>
+          <p:cNvSpPr/>
+          <p:nvPr/>
+        </p:nvSpPr>
+        <p:spPr>
+          <a:xfrm>
+            <a:off x="10104120" y="749880"/>
+            <a:ext cx="1993392" cy="435600"/>
+          </a:xfrm>
+          <a:prstGeom prst="roundRect">
+            <a:avLst>
+              <a:gd name="adj" fmla="val 16667"/>
+            </a:avLst>
+          </a:prstGeom>
+          <a:solidFill>
+            <a:srgbClr val="C0392B"/>
+          </a:solidFill>
+          <a:ln>
+            <a:noFill/>
+          </a:ln>
+          <a:effectLst>
+            <a:outerShdw blurRad="39960" dir="5400000" dist="23040" rotWithShape="0">
+              <a:srgbClr val="000000">
+                <a:alpha val="35000"/>
+              </a:srgbClr>
+            </a:outerShdw>
+          </a:effectLst>
+        </p:spPr>
+        <p:style>
+          <a:lnRef idx="1">
+            <a:schemeClr val="accent1"/>
+          </a:lnRef>
+          <a:fillRef idx="3">
+            <a:schemeClr val="accent1"/>
+          </a:fillRef>
+          <a:effectRef idx="2">
+            <a:schemeClr val="accent1"/>
+          </a:effectRef>
+          <a:fontRef idx="minor"/>
+        </p:style>
+        <p:txBody>
+          <a:bodyPr lIns="73080" tIns="54720" rIns="73080" bIns="54720" anchor="ctr">
+            <a:noAutofit/>
+          </a:bodyPr>
+          <a:p>
+            <a:pPr algn="ctr" defTabSz="457200">
+              <a:lnSpc>
+                <a:spcPct val="100000"/>
+              </a:lnSpc>
+            </a:pPr>
+            <a:r>
+              <a:rPr lang="en-US" sz="1500" b="1" u="none" strike="noStrike">
+                <a:solidFill>
+                  <a:srgbClr val="FFFFFF"/>
+                </a:solidFill>
+                <a:effectLst/>
+                <a:uFillTx/>
+                <a:latin typeface="Calibri"/>
+              </a:rPr>
+              <a:t>SQL Agent</a:t>
+            </a:r>
+            <a:endParaRPr lang="en-US" sz="1500" b="0" u="none" strike="noStrike">
+              <a:solidFill>
+                <a:srgbClr val="FFFFFF"/>
+              </a:solidFill>
+              <a:effectLst/>
+              <a:uFillTx/>
+              <a:latin typeface="Arial"/>
+            </a:endParaRPr>
+          </a:p>
+        </p:txBody>
+      </p:sp>
+      <p:sp>
+        <p:nvSpPr>
+          <p:cNvPr id="471" name="Rounded Rectangle 83"/>
+          <p:cNvSpPr/>
+          <p:nvPr/>
+        </p:nvSpPr>
+        <p:spPr>
+          <a:xfrm>
+            <a:off x="10104120" y="1280160"/>
+            <a:ext cx="1993392" cy="655200"/>
+          </a:xfrm>
+          <a:prstGeom prst="roundRect">
+            <a:avLst>
+              <a:gd name="adj" fmla="val 16667"/>
+            </a:avLst>
+          </a:prstGeom>
+          <a:solidFill>
+            <a:srgbClr val="E8ECF0"/>
+          </a:solidFill>
+          <a:ln w="12700">
+            <a:solidFill>
+              <a:srgbClr val="909AA8"/>
+            </a:solidFill>
+            <a:round/>
+          </a:ln>
+          <a:effectLst>
+            <a:outerShdw blurRad="39960" dir="5400000" dist="23040" rotWithShape="0">
+              <a:srgbClr val="000000">
+                <a:alpha val="35000"/>
+              </a:srgbClr>
+            </a:outerShdw>
+          </a:effectLst>
+        </p:spPr>
+        <p:style>
+          <a:lnRef idx="1">
+            <a:schemeClr val="accent1"/>
+          </a:lnRef>
+          <a:fillRef idx="3">
+            <a:schemeClr val="accent1"/>
+          </a:fillRef>
+          <a:effectRef idx="2">
+            <a:schemeClr val="accent1"/>
+          </a:effectRef>
+          <a:fontRef idx="minor"/>
+        </p:style>
+        <p:txBody>
+          <a:bodyPr lIns="73080" tIns="54720" rIns="73080" bIns="54720" anchor="ctr">
+            <a:noAutofit/>
+          </a:bodyPr>
+          <a:p>
+            <a:pPr algn="ctr" defTabSz="457200">
+              <a:lnSpc>
+                <a:spcPct val="100000"/>
+              </a:lnSpc>
+            </a:pPr>
+            <a:r>
+              <a:rPr lang="en-US" sz="1200" b="0" u="none" strike="noStrike">
+                <a:solidFill>
+                  <a:srgbClr val="1A1A2E"/>
+                </a:solidFill>
+                <a:effectLst/>
+                <a:uFillTx/>
+                <a:latin typeface="Calibri"/>
+              </a:rPr>
+              <a:t>Claude Sonnet 4.6</a:t>
+            </a:r>
+            <a:endParaRPr lang="en-US" sz="1200" b="0" u="none" strike="noStrike">
+              <a:solidFill>
+                <a:srgbClr val="000000"/>
+              </a:solidFill>
+              <a:effectLst/>
+              <a:uFillTx/>
+              <a:latin typeface="Arial"/>
+            </a:endParaRPr>
+          </a:p>
+        </p:txBody>
+      </p:sp>
+      <p:sp>
+        <p:nvSpPr>
+          <p:cNvPr id="476" name="Rounded Rectangle 88"/>
+          <p:cNvSpPr/>
+          <p:nvPr/>
+        </p:nvSpPr>
+        <p:spPr>
+          <a:xfrm>
+            <a:off x="10104120" y="2030040"/>
+            <a:ext cx="1993392" cy="655200"/>
+          </a:xfrm>
+          <a:prstGeom prst="roundRect">
+            <a:avLst>
+              <a:gd name="adj" fmla="val 16667"/>
+            </a:avLst>
+          </a:prstGeom>
+          <a:solidFill>
+            <a:srgbClr val="FFFFFF"/>
+          </a:solidFill>
+          <a:ln w="12700">
+            <a:solidFill>
+              <a:srgbClr val="909AA8"/>
+            </a:solidFill>
+            <a:round/>
+          </a:ln>
+          <a:effectLst>
+            <a:outerShdw blurRad="39960" dir="5400000" dist="23040" rotWithShape="0">
+              <a:srgbClr val="000000">
+                <a:alpha val="35000"/>
+              </a:srgbClr>
+            </a:outerShdw>
+          </a:effectLst>
+        </p:spPr>
+        <p:style>
+          <a:lnRef idx="1">
+            <a:schemeClr val="accent1"/>
+          </a:lnRef>
+          <a:fillRef idx="3">
+            <a:schemeClr val="accent1"/>
+          </a:fillRef>
+          <a:effectRef idx="2">
+            <a:schemeClr val="accent1"/>
+          </a:effectRef>
+          <a:fontRef idx="minor"/>
+        </p:style>
+        <p:txBody>
+          <a:bodyPr lIns="73080" tIns="54720" rIns="73080" bIns="54720" anchor="ctr">
+            <a:noAutofit/>
+          </a:bodyPr>
+          <a:p>
+            <a:pPr algn="ctr" defTabSz="457200">
+              <a:lnSpc>
+                <a:spcPct val="100000"/>
+              </a:lnSpc>
+            </a:pPr>
+            <a:r>
+              <a:rPr lang="en-US" sz="1200" b="0" u="none" strike="noStrike">
+                <a:solidFill>
+                  <a:srgbClr val="1A1A2E"/>
+                </a:solidFill>
+                <a:effectLst/>
+                <a:uFillTx/>
+                <a:latin typeface="Calibri"/>
+              </a:rPr>
+              <a:t>33k (SQLite)</a:t>
+            </a:r>
+            <a:endParaRPr lang="en-US" sz="1200" b="0" u="none" strike="noStrike">
+              <a:solidFill>
+                <a:srgbClr val="000000"/>
+              </a:solidFill>
+              <a:effectLst/>
+              <a:uFillTx/>
+              <a:latin typeface="Arial"/>
+            </a:endParaRPr>
+          </a:p>
+        </p:txBody>
+      </p:sp>
+      <p:sp>
+        <p:nvSpPr>
+          <p:cNvPr id="481" name="Rounded Rectangle 93"/>
+          <p:cNvSpPr/>
+          <p:nvPr/>
+        </p:nvSpPr>
+        <p:spPr>
+          <a:xfrm>
+            <a:off x="10104120" y="2779920"/>
+            <a:ext cx="1993392" cy="655200"/>
+          </a:xfrm>
+          <a:prstGeom prst="roundRect">
+            <a:avLst>
+              <a:gd name="adj" fmla="val 16667"/>
+            </a:avLst>
+          </a:prstGeom>
+          <a:solidFill>
+            <a:srgbClr val="E8ECF0"/>
+          </a:solidFill>
+          <a:ln w="12700">
+            <a:solidFill>
+              <a:srgbClr val="909AA8"/>
+            </a:solidFill>
+            <a:round/>
+          </a:ln>
+          <a:effectLst>
+            <a:outerShdw blurRad="39960" dir="5400000" dist="23040" rotWithShape="0">
+              <a:srgbClr val="000000">
+                <a:alpha val="35000"/>
+              </a:srgbClr>
+            </a:outerShdw>
+          </a:effectLst>
+        </p:spPr>
+        <p:style>
+          <a:lnRef idx="1">
+            <a:schemeClr val="accent1"/>
+          </a:lnRef>
+          <a:fillRef idx="3">
+            <a:schemeClr val="accent1"/>
+          </a:fillRef>
+          <a:effectRef idx="2">
+            <a:schemeClr val="accent1"/>
+          </a:effectRef>
+          <a:fontRef idx="minor"/>
+        </p:style>
+        <p:txBody>
+          <a:bodyPr lIns="73080" tIns="54720" rIns="73080" bIns="54720" anchor="ctr">
+            <a:noAutofit/>
+          </a:bodyPr>
+          <a:p>
+            <a:pPr algn="ctr" defTabSz="457200">
+              <a:lnSpc>
+                <a:spcPct val="100000"/>
+              </a:lnSpc>
+            </a:pPr>
+            <a:r>
+              <a:rPr lang="en-US" sz="1200" b="0" u="none" strike="noStrike">
+                <a:solidFill>
+                  <a:srgbClr val="1A1A2E"/>
+                </a:solidFill>
+                <a:effectLst/>
+                <a:uFillTx/>
+                <a:latin typeface="Calibri"/>
+              </a:rPr>
+              <a:t>NL &gt; SQL &gt; DB</a:t>
+            </a:r>
+            <a:endParaRPr lang="en-US" sz="1200" b="0" u="none" strike="noStrike">
+              <a:solidFill>
+                <a:srgbClr val="000000"/>
+              </a:solidFill>
+              <a:effectLst/>
+              <a:uFillTx/>
+              <a:latin typeface="Arial"/>
+            </a:endParaRPr>
+          </a:p>
+        </p:txBody>
+      </p:sp>
+      <p:sp>
+        <p:nvSpPr>
+          <p:cNvPr id="486" name="Rounded Rectangle 98"/>
+          <p:cNvSpPr/>
+          <p:nvPr/>
+        </p:nvSpPr>
+        <p:spPr>
+          <a:xfrm>
+            <a:off x="10104120" y="3529440"/>
+            <a:ext cx="1993392" cy="655200"/>
+          </a:xfrm>
+          <a:prstGeom prst="roundRect">
+            <a:avLst>
+              <a:gd name="adj" fmla="val 16667"/>
+            </a:avLst>
+          </a:prstGeom>
+          <a:solidFill>
+            <a:srgbClr val="FFFFFF"/>
+          </a:solidFill>
+          <a:ln w="12700">
+            <a:solidFill>
+              <a:srgbClr val="909AA8"/>
+            </a:solidFill>
+            <a:round/>
+          </a:ln>
+          <a:effectLst>
+            <a:outerShdw blurRad="39960" dir="5400000" dist="23040" rotWithShape="0">
+              <a:srgbClr val="000000">
+                <a:alpha val="35000"/>
+              </a:srgbClr>
+            </a:outerShdw>
+          </a:effectLst>
+        </p:spPr>
+        <p:style>
+          <a:lnRef idx="1">
+            <a:schemeClr val="accent1"/>
+          </a:lnRef>
+          <a:fillRef idx="3">
+            <a:schemeClr val="accent1"/>
+          </a:fillRef>
+          <a:effectRef idx="2">
+            <a:schemeClr val="accent1"/>
+          </a:effectRef>
+          <a:fontRef idx="minor"/>
+        </p:style>
+        <p:txBody>
+          <a:bodyPr lIns="73080" tIns="54720" rIns="73080" bIns="54720" anchor="ctr">
+            <a:noAutofit/>
+          </a:bodyPr>
+          <a:p>
+            <a:pPr algn="ctr" defTabSz="457200">
+              <a:lnSpc>
+                <a:spcPct val="100000"/>
+              </a:lnSpc>
+            </a:pPr>
+            <a:r>
+              <a:rPr lang="en-US" sz="1200" b="0" u="none" strike="noStrike">
+                <a:solidFill>
+                  <a:srgbClr val="1A1A2E"/>
+                </a:solidFill>
+                <a:effectLst/>
+                <a:uFillTx/>
+                <a:latin typeface="Calibri"/>
+              </a:rPr>
+              <a:t>~$0.30</a:t>
+            </a:r>
+            <a:endParaRPr lang="en-US" sz="1200" b="0" u="none" strike="noStrike">
+              <a:solidFill>
+                <a:srgbClr val="000000"/>
+              </a:solidFill>
+              <a:effectLst/>
+              <a:uFillTx/>
+              <a:latin typeface="Arial"/>
+            </a:endParaRPr>
+          </a:p>
+        </p:txBody>
+      </p:sp>
+      <p:sp>
+        <p:nvSpPr>
+          <p:cNvPr id="491" name="Rounded Rectangle 103"/>
+          <p:cNvSpPr/>
+          <p:nvPr/>
+        </p:nvSpPr>
+        <p:spPr>
+          <a:xfrm>
+            <a:off x="10104120" y="4279320"/>
+            <a:ext cx="1993392" cy="655200"/>
+          </a:xfrm>
+          <a:prstGeom prst="roundRect">
+            <a:avLst>
+              <a:gd name="adj" fmla="val 16667"/>
+            </a:avLst>
+          </a:prstGeom>
+          <a:solidFill>
+            <a:srgbClr val="E8ECF0"/>
+          </a:solidFill>
+          <a:ln w="12700">
+            <a:solidFill>
+              <a:srgbClr val="909AA8"/>
+            </a:solidFill>
+            <a:round/>
+          </a:ln>
+          <a:effectLst>
+            <a:outerShdw blurRad="39960" dir="5400000" dist="23040" rotWithShape="0">
+              <a:srgbClr val="000000">
+                <a:alpha val="35000"/>
+              </a:srgbClr>
+            </a:outerShdw>
+          </a:effectLst>
+        </p:spPr>
+        <p:style>
+          <a:lnRef idx="1">
+            <a:schemeClr val="accent1"/>
+          </a:lnRef>
+          <a:fillRef idx="3">
+            <a:schemeClr val="accent1"/>
+          </a:fillRef>
+          <a:effectRef idx="2">
+            <a:schemeClr val="accent1"/>
+          </a:effectRef>
+          <a:fontRef idx="minor"/>
+        </p:style>
+        <p:txBody>
+          <a:bodyPr lIns="73080" tIns="54720" rIns="73080" bIns="54720" anchor="ctr">
+            <a:noAutofit/>
+          </a:bodyPr>
+          <a:p>
+            <a:pPr algn="ctr" defTabSz="457200">
+              <a:lnSpc>
+                <a:spcPct val="100000"/>
+              </a:lnSpc>
+            </a:pPr>
+            <a:r>
+              <a:rPr lang="en-US" sz="1200" b="0" u="none" strike="noStrike">
+                <a:solidFill>
+                  <a:srgbClr val="1A1A2E"/>
+                </a:solidFill>
+                <a:effectLst/>
+                <a:uFillTx/>
+                <a:latin typeface="Calibri"/>
+              </a:rPr>
+              <a:t>9.5/10†</a:t>
+            </a:r>
+            <a:endParaRPr lang="en-US" sz="1200" b="0" u="none" strike="noStrike">
+              <a:solidFill>
+                <a:srgbClr val="000000"/>
+              </a:solidFill>
+              <a:effectLst/>
+              <a:uFillTx/>
+              <a:latin typeface="Arial"/>
+            </a:endParaRPr>
+          </a:p>
+        </p:txBody>
+      </p:sp>
+      <p:sp>
+        <p:nvSpPr>
+          <p:cNvPr id="496" name="Rounded Rectangle 108"/>
+          <p:cNvSpPr/>
+          <p:nvPr/>
+        </p:nvSpPr>
+        <p:spPr>
+          <a:xfrm>
+            <a:off x="10104120" y="5029200"/>
+            <a:ext cx="1993392" cy="655200"/>
+          </a:xfrm>
+          <a:prstGeom prst="roundRect">
+            <a:avLst>
+              <a:gd name="adj" fmla="val 16667"/>
+            </a:avLst>
+          </a:prstGeom>
+          <a:solidFill>
+            <a:srgbClr val="FFFFFF"/>
+          </a:solidFill>
+          <a:ln w="12700">
+            <a:solidFill>
+              <a:srgbClr val="909AA8"/>
+            </a:solidFill>
+            <a:round/>
+          </a:ln>
+          <a:effectLst>
+            <a:outerShdw blurRad="39960" dir="5400000" dist="23040" rotWithShape="0">
+              <a:srgbClr val="000000">
+                <a:alpha val="35000"/>
+              </a:srgbClr>
+            </a:outerShdw>
+          </a:effectLst>
+        </p:spPr>
+        <p:style>
+          <a:lnRef idx="1">
+            <a:schemeClr val="accent1"/>
+          </a:lnRef>
+          <a:fillRef idx="3">
+            <a:schemeClr val="accent1"/>
+          </a:fillRef>
+          <a:effectRef idx="2">
+            <a:schemeClr val="accent1"/>
+          </a:effectRef>
+          <a:fontRef idx="minor"/>
+        </p:style>
+        <p:txBody>
+          <a:bodyPr lIns="73080" tIns="54720" rIns="73080" bIns="54720" anchor="ctr">
+            <a:noAutofit/>
+          </a:bodyPr>
+          <a:p>
+            <a:pPr algn="ctr" defTabSz="457200">
+              <a:lnSpc>
+                <a:spcPct val="100000"/>
+              </a:lnSpc>
+            </a:pPr>
+            <a:r>
+              <a:rPr lang="en-US" sz="1200" b="0" u="none" strike="noStrike">
+                <a:solidFill>
+                  <a:srgbClr val="1A1A2E"/>
+                </a:solidFill>
+                <a:effectLst/>
+                <a:uFillTx/>
+                <a:latin typeface="Calibri"/>
+              </a:rPr>
+              <a:t>Dev-familiar</a:t>
+            </a:r>
+            <a:endParaRPr lang="en-US" sz="1200" b="0" u="none" strike="noStrike">
+              <a:solidFill>
+                <a:srgbClr val="000000"/>
               </a:solidFill>
               <a:effectLst/>
               <a:uFillTx/>
@@ -46132,6 +47258,21 @@
               <a:latin typeface="Arial"/>
             </a:endParaRPr>
           </a:p>
+          <a:p>
+            <a:pPr>
+              <a:lnSpc>
+                <a:spcPct val="100000"/>
+              </a:lnSpc>
+            </a:pPr>
+            <a:endParaRPr lang="en-US" sz="1800" b="0" u="none" strike="noStrike">
+              <a:solidFill>
+                <a:srgbClr val="000000"/>
+              </a:solidFill>
+              <a:effectLst/>
+              <a:uFillTx/>
+              <a:latin typeface="Arial"/>
+            </a:endParaRPr>
+          </a:p>
         </p:txBody>
       </p:sp>
     </p:spTree>
@@ -48081,7 +49222,7 @@
         <p:spPr>
           <a:xfrm>
             <a:off x="2130480" y="749880"/>
-            <a:ext cx="2465640" cy="435600"/>
+            <a:ext cx="1993392" cy="435600"/>
           </a:xfrm>
           <a:prstGeom prst="roundRect">
             <a:avLst>
@@ -48154,8 +49295,8 @@
         </p:nvSpPr>
         <p:spPr>
           <a:xfrm>
-            <a:off x="4626720" y="749880"/>
-            <a:ext cx="2465640" cy="435600"/>
+            <a:off x="4123944" y="749880"/>
+            <a:ext cx="1993392" cy="435600"/>
           </a:xfrm>
           <a:prstGeom prst="roundRect">
             <a:avLst>
@@ -48228,8 +49369,8 @@
         </p:nvSpPr>
         <p:spPr>
           <a:xfrm>
-            <a:off x="7123320" y="749880"/>
-            <a:ext cx="2465640" cy="435600"/>
+            <a:off x="6117336" y="749880"/>
+            <a:ext cx="1993392" cy="435600"/>
           </a:xfrm>
           <a:prstGeom prst="roundRect">
             <a:avLst>
@@ -48302,8 +49443,8 @@
         </p:nvSpPr>
         <p:spPr>
           <a:xfrm>
-            <a:off x="9619560" y="749880"/>
-            <a:ext cx="2465640" cy="435600"/>
+            <a:off x="8110727" y="749880"/>
+            <a:ext cx="1993392" cy="435600"/>
           </a:xfrm>
           <a:prstGeom prst="roundRect">
             <a:avLst>
@@ -48451,7 +49592,7 @@
         <p:spPr>
           <a:xfrm>
             <a:off x="2130480" y="1280160"/>
-            <a:ext cx="2465640" cy="655200"/>
+            <a:ext cx="1993392" cy="655200"/>
           </a:xfrm>
           <a:prstGeom prst="roundRect">
             <a:avLst>
@@ -48527,8 +49668,8 @@
         </p:nvSpPr>
         <p:spPr>
           <a:xfrm>
-            <a:off x="4626720" y="1280160"/>
-            <a:ext cx="2465640" cy="655200"/>
+            <a:off x="4123944" y="1280160"/>
+            <a:ext cx="1993392" cy="655200"/>
           </a:xfrm>
           <a:prstGeom prst="roundRect">
             <a:avLst>
@@ -48604,8 +49745,8 @@
         </p:nvSpPr>
         <p:spPr>
           <a:xfrm>
-            <a:off x="7123320" y="1280160"/>
-            <a:ext cx="2465640" cy="655200"/>
+            <a:off x="6117336" y="1280160"/>
+            <a:ext cx="1993392" cy="655200"/>
           </a:xfrm>
           <a:prstGeom prst="roundRect">
             <a:avLst>
@@ -48681,8 +49822,8 @@
         </p:nvSpPr>
         <p:spPr>
           <a:xfrm>
-            <a:off x="9619560" y="1280160"/>
-            <a:ext cx="2465640" cy="655200"/>
+            <a:off x="8110727" y="1280160"/>
+            <a:ext cx="1993392" cy="655200"/>
           </a:xfrm>
           <a:prstGeom prst="roundRect">
             <a:avLst>
@@ -48833,7 +49974,7 @@
         <p:spPr>
           <a:xfrm>
             <a:off x="2130480" y="2030040"/>
-            <a:ext cx="2465640" cy="655200"/>
+            <a:ext cx="1993392" cy="655200"/>
           </a:xfrm>
           <a:prstGeom prst="roundRect">
             <a:avLst>
@@ -48909,8 +50050,8 @@
         </p:nvSpPr>
         <p:spPr>
           <a:xfrm>
-            <a:off x="4626720" y="2030040"/>
-            <a:ext cx="2465640" cy="655200"/>
+            <a:off x="4123944" y="2030040"/>
+            <a:ext cx="1993392" cy="655200"/>
           </a:xfrm>
           <a:prstGeom prst="roundRect">
             <a:avLst>
@@ -48986,8 +50127,8 @@
         </p:nvSpPr>
         <p:spPr>
           <a:xfrm>
-            <a:off x="7123320" y="2030040"/>
-            <a:ext cx="2465640" cy="655200"/>
+            <a:off x="6117336" y="2030040"/>
+            <a:ext cx="1993392" cy="655200"/>
           </a:xfrm>
           <a:prstGeom prst="roundRect">
             <a:avLst>
@@ -49063,8 +50204,8 @@
         </p:nvSpPr>
         <p:spPr>
           <a:xfrm>
-            <a:off x="9619560" y="2030040"/>
-            <a:ext cx="2465640" cy="655200"/>
+            <a:off x="8110727" y="2030040"/>
+            <a:ext cx="1993392" cy="655200"/>
           </a:xfrm>
           <a:prstGeom prst="roundRect">
             <a:avLst>
@@ -49215,7 +50356,7 @@
         <p:spPr>
           <a:xfrm>
             <a:off x="2130480" y="2779920"/>
-            <a:ext cx="2465640" cy="655200"/>
+            <a:ext cx="1993392" cy="655200"/>
           </a:xfrm>
           <a:prstGeom prst="roundRect">
             <a:avLst>
@@ -49291,8 +50432,8 @@
         </p:nvSpPr>
         <p:spPr>
           <a:xfrm>
-            <a:off x="4626720" y="2779920"/>
-            <a:ext cx="2465640" cy="655200"/>
+            <a:off x="4123944" y="2779920"/>
+            <a:ext cx="1993392" cy="655200"/>
           </a:xfrm>
           <a:prstGeom prst="roundRect">
             <a:avLst>
@@ -49368,8 +50509,8 @@
         </p:nvSpPr>
         <p:spPr>
           <a:xfrm>
-            <a:off x="7123320" y="2779920"/>
-            <a:ext cx="2465640" cy="655200"/>
+            <a:off x="6117336" y="2779920"/>
+            <a:ext cx="1993392" cy="655200"/>
           </a:xfrm>
           <a:prstGeom prst="roundRect">
             <a:avLst>
@@ -49445,8 +50586,8 @@
         </p:nvSpPr>
         <p:spPr>
           <a:xfrm>
-            <a:off x="9619560" y="2779920"/>
-            <a:ext cx="2465640" cy="655200"/>
+            <a:off x="8110727" y="2779920"/>
+            <a:ext cx="1993392" cy="655200"/>
           </a:xfrm>
           <a:prstGeom prst="roundRect">
             <a:avLst>
@@ -49597,7 +50738,7 @@
         <p:spPr>
           <a:xfrm>
             <a:off x="2130480" y="3529440"/>
-            <a:ext cx="2465640" cy="655200"/>
+            <a:ext cx="1993392" cy="655200"/>
           </a:xfrm>
           <a:prstGeom prst="roundRect">
             <a:avLst>
@@ -49673,8 +50814,8 @@
         </p:nvSpPr>
         <p:spPr>
           <a:xfrm>
-            <a:off x="4626720" y="3529440"/>
-            <a:ext cx="2465640" cy="655200"/>
+            <a:off x="4123944" y="3529440"/>
+            <a:ext cx="1993392" cy="655200"/>
           </a:xfrm>
           <a:prstGeom prst="roundRect">
             <a:avLst>
@@ -49750,8 +50891,8 @@
         </p:nvSpPr>
         <p:spPr>
           <a:xfrm>
-            <a:off x="7123320" y="3529440"/>
-            <a:ext cx="2465640" cy="655200"/>
+            <a:off x="6117336" y="3529440"/>
+            <a:ext cx="1993392" cy="655200"/>
           </a:xfrm>
           <a:prstGeom prst="roundRect">
             <a:avLst>
@@ -49827,8 +50968,8 @@
         </p:nvSpPr>
         <p:spPr>
           <a:xfrm>
-            <a:off x="9619560" y="3529440"/>
-            <a:ext cx="2465640" cy="655200"/>
+            <a:off x="8110727" y="3529440"/>
+            <a:ext cx="1993392" cy="655200"/>
           </a:xfrm>
           <a:prstGeom prst="roundRect">
             <a:avLst>
@@ -49979,7 +51120,7 @@
         <p:spPr>
           <a:xfrm>
             <a:off x="2130480" y="4279320"/>
-            <a:ext cx="2465640" cy="655200"/>
+            <a:ext cx="1993392" cy="655200"/>
           </a:xfrm>
           <a:prstGeom prst="roundRect">
             <a:avLst>
@@ -50055,8 +51196,8 @@
         </p:nvSpPr>
         <p:spPr>
           <a:xfrm>
-            <a:off x="4626720" y="4279320"/>
-            <a:ext cx="2465640" cy="655200"/>
+            <a:off x="4123944" y="4279320"/>
+            <a:ext cx="1993392" cy="655200"/>
           </a:xfrm>
           <a:prstGeom prst="roundRect">
             <a:avLst>
@@ -50132,8 +51273,8 @@
         </p:nvSpPr>
         <p:spPr>
           <a:xfrm>
-            <a:off x="7123320" y="4279320"/>
-            <a:ext cx="2465640" cy="655200"/>
+            <a:off x="6117336" y="4279320"/>
+            <a:ext cx="1993392" cy="655200"/>
           </a:xfrm>
           <a:prstGeom prst="roundRect">
             <a:avLst>
@@ -50209,8 +51350,8 @@
         </p:nvSpPr>
         <p:spPr>
           <a:xfrm>
-            <a:off x="9619560" y="4279320"/>
-            <a:ext cx="2465640" cy="655200"/>
+            <a:off x="8110727" y="4279320"/>
+            <a:ext cx="1993392" cy="655200"/>
           </a:xfrm>
           <a:prstGeom prst="roundRect">
             <a:avLst>
@@ -50361,7 +51502,7 @@
         <p:spPr>
           <a:xfrm>
             <a:off x="2130480" y="5029200"/>
-            <a:ext cx="2465640" cy="655200"/>
+            <a:ext cx="1993392" cy="655200"/>
           </a:xfrm>
           <a:prstGeom prst="roundRect">
             <a:avLst>
@@ -50437,8 +51578,8 @@
         </p:nvSpPr>
         <p:spPr>
           <a:xfrm>
-            <a:off x="4626720" y="5029200"/>
-            <a:ext cx="2465640" cy="655200"/>
+            <a:off x="4123944" y="5029200"/>
+            <a:ext cx="1993392" cy="655200"/>
           </a:xfrm>
           <a:prstGeom prst="roundRect">
             <a:avLst>
@@ -50514,8 +51655,8 @@
         </p:nvSpPr>
         <p:spPr>
           <a:xfrm>
-            <a:off x="7123320" y="5029200"/>
-            <a:ext cx="2465640" cy="655200"/>
+            <a:off x="6117336" y="5029200"/>
+            <a:ext cx="1993392" cy="655200"/>
           </a:xfrm>
           <a:prstGeom prst="roundRect">
             <a:avLst>
@@ -50591,8 +51732,8 @@
         </p:nvSpPr>
         <p:spPr>
           <a:xfrm>
-            <a:off x="9619560" y="5029200"/>
-            <a:ext cx="2465640" cy="655200"/>
+            <a:off x="8110727" y="5029200"/>
+            <a:ext cx="1993392" cy="655200"/>
           </a:xfrm>
           <a:prstGeom prst="roundRect">
             <a:avLst>
@@ -50669,7 +51810,7 @@
         <p:spPr>
           <a:xfrm>
             <a:off x="2130480" y="2030400"/>
-            <a:ext cx="9982800" cy="3654000"/>
+            <a:ext cx="1993392" cy="3654000"/>
           </a:xfrm>
           <a:prstGeom prst="rect">
             <a:avLst/>
@@ -50713,8 +51854,8 @@
         </p:nvSpPr>
         <p:spPr>
           <a:xfrm>
-            <a:off x="7124040" y="749880"/>
-            <a:ext cx="2465640" cy="435600"/>
+            <a:off x="6117336" y="749880"/>
+            <a:ext cx="1993392" cy="435600"/>
           </a:xfrm>
           <a:prstGeom prst="roundRect">
             <a:avLst>
@@ -50787,8 +51928,8 @@
         </p:nvSpPr>
         <p:spPr>
           <a:xfrm>
-            <a:off x="7124040" y="749880"/>
-            <a:ext cx="2465640" cy="435600"/>
+            <a:off x="6117336" y="749880"/>
+            <a:ext cx="1993392" cy="435600"/>
           </a:xfrm>
           <a:prstGeom prst="roundRect">
             <a:avLst>
@@ -50845,6 +51986,542 @@
             <a:endParaRPr lang="en-US" sz="1500" b="0" u="none" strike="noStrike">
               <a:solidFill>
                 <a:srgbClr val="FFFFFF"/>
+              </a:solidFill>
+              <a:effectLst/>
+              <a:uFillTx/>
+              <a:latin typeface="Arial"/>
+            </a:endParaRPr>
+          </a:p>
+        </p:txBody>
+      </p:sp>
+      <p:sp>
+        <p:nvSpPr>
+          <p:cNvPr id="139" name="Rounded Rectangle 6"/>
+          <p:cNvSpPr/>
+          <p:nvPr/>
+        </p:nvSpPr>
+        <p:spPr>
+          <a:xfrm>
+            <a:off x="10104120" y="749880"/>
+            <a:ext cx="1993392" cy="435600"/>
+          </a:xfrm>
+          <a:prstGeom prst="roundRect">
+            <a:avLst>
+              <a:gd name="adj" fmla="val 16667"/>
+            </a:avLst>
+          </a:prstGeom>
+          <a:solidFill>
+            <a:srgbClr val="C0392B"/>
+          </a:solidFill>
+          <a:ln>
+            <a:noFill/>
+          </a:ln>
+          <a:effectLst>
+            <a:outerShdw blurRad="39960" dir="5400000" dist="23040" rotWithShape="0">
+              <a:srgbClr val="000000">
+                <a:alpha val="35000"/>
+              </a:srgbClr>
+            </a:outerShdw>
+          </a:effectLst>
+        </p:spPr>
+        <p:style>
+          <a:lnRef idx="1">
+            <a:schemeClr val="accent1"/>
+          </a:lnRef>
+          <a:fillRef idx="3">
+            <a:schemeClr val="accent1"/>
+          </a:fillRef>
+          <a:effectRef idx="2">
+            <a:schemeClr val="accent1"/>
+          </a:effectRef>
+          <a:fontRef idx="minor"/>
+        </p:style>
+        <p:txBody>
+          <a:bodyPr lIns="73080" tIns="54720" rIns="73080" bIns="54720" anchor="ctr">
+            <a:noAutofit/>
+          </a:bodyPr>
+          <a:p>
+            <a:pPr algn="ctr" defTabSz="457200">
+              <a:lnSpc>
+                <a:spcPct val="100000"/>
+              </a:lnSpc>
+            </a:pPr>
+            <a:r>
+              <a:rPr lang="en-US" sz="1500" b="1" u="none" strike="noStrike">
+                <a:solidFill>
+                  <a:srgbClr val="FFFFFF"/>
+                </a:solidFill>
+                <a:effectLst/>
+                <a:uFillTx/>
+                <a:latin typeface="Calibri"/>
+              </a:rPr>
+              <a:t>SQL Agent</a:t>
+            </a:r>
+            <a:endParaRPr lang="en-US" sz="1500" b="0" u="none" strike="noStrike">
+              <a:solidFill>
+                <a:srgbClr val="FFFFFF"/>
+              </a:solidFill>
+              <a:effectLst/>
+              <a:uFillTx/>
+              <a:latin typeface="Arial"/>
+            </a:endParaRPr>
+          </a:p>
+        </p:txBody>
+      </p:sp>
+      <p:sp>
+        <p:nvSpPr>
+          <p:cNvPr id="144" name="Rounded Rectangle 11"/>
+          <p:cNvSpPr/>
+          <p:nvPr/>
+        </p:nvSpPr>
+        <p:spPr>
+          <a:xfrm>
+            <a:off x="10104120" y="1280160"/>
+            <a:ext cx="1993392" cy="655200"/>
+          </a:xfrm>
+          <a:prstGeom prst="roundRect">
+            <a:avLst>
+              <a:gd name="adj" fmla="val 16667"/>
+            </a:avLst>
+          </a:prstGeom>
+          <a:solidFill>
+            <a:srgbClr val="E8ECF0"/>
+          </a:solidFill>
+          <a:ln w="12700">
+            <a:solidFill>
+              <a:srgbClr val="909AA8"/>
+            </a:solidFill>
+            <a:round/>
+          </a:ln>
+          <a:effectLst>
+            <a:outerShdw blurRad="39960" dir="5400000" dist="23040" rotWithShape="0">
+              <a:srgbClr val="000000">
+                <a:alpha val="35000"/>
+              </a:srgbClr>
+            </a:outerShdw>
+          </a:effectLst>
+        </p:spPr>
+        <p:style>
+          <a:lnRef idx="1">
+            <a:schemeClr val="accent1"/>
+          </a:lnRef>
+          <a:fillRef idx="3">
+            <a:schemeClr val="accent1"/>
+          </a:fillRef>
+          <a:effectRef idx="2">
+            <a:schemeClr val="accent1"/>
+          </a:effectRef>
+          <a:fontRef idx="minor"/>
+        </p:style>
+        <p:txBody>
+          <a:bodyPr lIns="73080" tIns="54720" rIns="73080" bIns="54720" anchor="ctr">
+            <a:noAutofit/>
+          </a:bodyPr>
+          <a:p>
+            <a:pPr algn="ctr" defTabSz="457200">
+              <a:lnSpc>
+                <a:spcPct val="100000"/>
+              </a:lnSpc>
+            </a:pPr>
+            <a:r>
+              <a:rPr lang="en-US" sz="1200" b="0" u="none" strike="noStrike">
+                <a:solidFill>
+                  <a:srgbClr val="1A1A2E"/>
+                </a:solidFill>
+                <a:effectLst/>
+                <a:uFillTx/>
+                <a:latin typeface="Calibri"/>
+              </a:rPr>
+              <a:t>Claude Sonnet 4.6</a:t>
+            </a:r>
+            <a:endParaRPr lang="en-US" sz="1200" b="0" u="none" strike="noStrike">
+              <a:solidFill>
+                <a:srgbClr val="000000"/>
+              </a:solidFill>
+              <a:effectLst/>
+              <a:uFillTx/>
+              <a:latin typeface="Arial"/>
+            </a:endParaRPr>
+          </a:p>
+        </p:txBody>
+      </p:sp>
+      <p:sp>
+        <p:nvSpPr>
+          <p:cNvPr id="149" name="Rounded Rectangle 16"/>
+          <p:cNvSpPr/>
+          <p:nvPr/>
+        </p:nvSpPr>
+        <p:spPr>
+          <a:xfrm>
+            <a:off x="10104120" y="2030040"/>
+            <a:ext cx="1993392" cy="655200"/>
+          </a:xfrm>
+          <a:prstGeom prst="roundRect">
+            <a:avLst>
+              <a:gd name="adj" fmla="val 16667"/>
+            </a:avLst>
+          </a:prstGeom>
+          <a:solidFill>
+            <a:srgbClr val="FFFFFF"/>
+          </a:solidFill>
+          <a:ln w="12700">
+            <a:solidFill>
+              <a:srgbClr val="909AA8"/>
+            </a:solidFill>
+            <a:round/>
+          </a:ln>
+          <a:effectLst>
+            <a:outerShdw blurRad="39960" dir="5400000" dist="23040" rotWithShape="0">
+              <a:srgbClr val="000000">
+                <a:alpha val="35000"/>
+              </a:srgbClr>
+            </a:outerShdw>
+          </a:effectLst>
+        </p:spPr>
+        <p:style>
+          <a:lnRef idx="1">
+            <a:schemeClr val="accent1"/>
+          </a:lnRef>
+          <a:fillRef idx="3">
+            <a:schemeClr val="accent1"/>
+          </a:fillRef>
+          <a:effectRef idx="2">
+            <a:schemeClr val="accent1"/>
+          </a:effectRef>
+          <a:fontRef idx="minor"/>
+        </p:style>
+        <p:txBody>
+          <a:bodyPr lIns="73080" tIns="54720" rIns="73080" bIns="54720" anchor="ctr">
+            <a:noAutofit/>
+          </a:bodyPr>
+          <a:p>
+            <a:pPr algn="ctr" defTabSz="457200">
+              <a:lnSpc>
+                <a:spcPct val="100000"/>
+              </a:lnSpc>
+            </a:pPr>
+            <a:r>
+              <a:rPr lang="en-US" sz="1200" b="0" u="none" strike="noStrike">
+                <a:solidFill>
+                  <a:srgbClr val="1A1A2E"/>
+                </a:solidFill>
+                <a:effectLst/>
+                <a:uFillTx/>
+                <a:latin typeface="Calibri"/>
+              </a:rPr>
+              <a:t>33k (SQLite)</a:t>
+            </a:r>
+            <a:endParaRPr lang="en-US" sz="1200" b="0" u="none" strike="noStrike">
+              <a:solidFill>
+                <a:srgbClr val="000000"/>
+              </a:solidFill>
+              <a:effectLst/>
+              <a:uFillTx/>
+              <a:latin typeface="Arial"/>
+            </a:endParaRPr>
+          </a:p>
+        </p:txBody>
+      </p:sp>
+      <p:sp>
+        <p:nvSpPr>
+          <p:cNvPr id="154" name="Rounded Rectangle 21"/>
+          <p:cNvSpPr/>
+          <p:nvPr/>
+        </p:nvSpPr>
+        <p:spPr>
+          <a:xfrm>
+            <a:off x="10104120" y="2779920"/>
+            <a:ext cx="1993392" cy="655200"/>
+          </a:xfrm>
+          <a:prstGeom prst="roundRect">
+            <a:avLst>
+              <a:gd name="adj" fmla="val 16667"/>
+            </a:avLst>
+          </a:prstGeom>
+          <a:solidFill>
+            <a:srgbClr val="E8ECF0"/>
+          </a:solidFill>
+          <a:ln w="12700">
+            <a:solidFill>
+              <a:srgbClr val="909AA8"/>
+            </a:solidFill>
+            <a:round/>
+          </a:ln>
+          <a:effectLst>
+            <a:outerShdw blurRad="39960" dir="5400000" dist="23040" rotWithShape="0">
+              <a:srgbClr val="000000">
+                <a:alpha val="35000"/>
+              </a:srgbClr>
+            </a:outerShdw>
+          </a:effectLst>
+        </p:spPr>
+        <p:style>
+          <a:lnRef idx="1">
+            <a:schemeClr val="accent1"/>
+          </a:lnRef>
+          <a:fillRef idx="3">
+            <a:schemeClr val="accent1"/>
+          </a:fillRef>
+          <a:effectRef idx="2">
+            <a:schemeClr val="accent1"/>
+          </a:effectRef>
+          <a:fontRef idx="minor"/>
+        </p:style>
+        <p:txBody>
+          <a:bodyPr lIns="73080" tIns="54720" rIns="73080" bIns="54720" anchor="ctr">
+            <a:noAutofit/>
+          </a:bodyPr>
+          <a:p>
+            <a:pPr algn="ctr" defTabSz="457200">
+              <a:lnSpc>
+                <a:spcPct val="100000"/>
+              </a:lnSpc>
+            </a:pPr>
+            <a:r>
+              <a:rPr lang="en-US" sz="1200" b="0" u="none" strike="noStrike">
+                <a:solidFill>
+                  <a:srgbClr val="1A1A2E"/>
+                </a:solidFill>
+                <a:effectLst/>
+                <a:uFillTx/>
+                <a:latin typeface="Calibri"/>
+              </a:rPr>
+              <a:t>NL &gt; SQL &gt; DB</a:t>
+            </a:r>
+            <a:endParaRPr lang="en-US" sz="1200" b="0" u="none" strike="noStrike">
+              <a:solidFill>
+                <a:srgbClr val="000000"/>
+              </a:solidFill>
+              <a:effectLst/>
+              <a:uFillTx/>
+              <a:latin typeface="Arial"/>
+            </a:endParaRPr>
+          </a:p>
+        </p:txBody>
+      </p:sp>
+      <p:sp>
+        <p:nvSpPr>
+          <p:cNvPr id="159" name="Rounded Rectangle 26"/>
+          <p:cNvSpPr/>
+          <p:nvPr/>
+        </p:nvSpPr>
+        <p:spPr>
+          <a:xfrm>
+            <a:off x="10104120" y="3529440"/>
+            <a:ext cx="1993392" cy="655200"/>
+          </a:xfrm>
+          <a:prstGeom prst="roundRect">
+            <a:avLst>
+              <a:gd name="adj" fmla="val 16667"/>
+            </a:avLst>
+          </a:prstGeom>
+          <a:solidFill>
+            <a:srgbClr val="FFFFFF"/>
+          </a:solidFill>
+          <a:ln w="12700">
+            <a:solidFill>
+              <a:srgbClr val="909AA8"/>
+            </a:solidFill>
+            <a:round/>
+          </a:ln>
+          <a:effectLst>
+            <a:outerShdw blurRad="39960" dir="5400000" dist="23040" rotWithShape="0">
+              <a:srgbClr val="000000">
+                <a:alpha val="35000"/>
+              </a:srgbClr>
+            </a:outerShdw>
+          </a:effectLst>
+        </p:spPr>
+        <p:style>
+          <a:lnRef idx="1">
+            <a:schemeClr val="accent1"/>
+          </a:lnRef>
+          <a:fillRef idx="3">
+            <a:schemeClr val="accent1"/>
+          </a:fillRef>
+          <a:effectRef idx="2">
+            <a:schemeClr val="accent1"/>
+          </a:effectRef>
+          <a:fontRef idx="minor"/>
+        </p:style>
+        <p:txBody>
+          <a:bodyPr lIns="73080" tIns="54720" rIns="73080" bIns="54720" anchor="ctr">
+            <a:noAutofit/>
+          </a:bodyPr>
+          <a:p>
+            <a:pPr algn="ctr" defTabSz="457200">
+              <a:lnSpc>
+                <a:spcPct val="100000"/>
+              </a:lnSpc>
+            </a:pPr>
+            <a:r>
+              <a:rPr lang="en-US" sz="1200" b="0" u="none" strike="noStrike">
+                <a:solidFill>
+                  <a:srgbClr val="1A1A2E"/>
+                </a:solidFill>
+                <a:effectLst/>
+                <a:uFillTx/>
+                <a:latin typeface="Calibri"/>
+              </a:rPr>
+              <a:t>~$0.30</a:t>
+            </a:r>
+            <a:endParaRPr lang="en-US" sz="1200" b="0" u="none" strike="noStrike">
+              <a:solidFill>
+                <a:srgbClr val="000000"/>
+              </a:solidFill>
+              <a:effectLst/>
+              <a:uFillTx/>
+              <a:latin typeface="Arial"/>
+            </a:endParaRPr>
+          </a:p>
+        </p:txBody>
+      </p:sp>
+      <p:sp>
+        <p:nvSpPr>
+          <p:cNvPr id="164" name="Rounded Rectangle 31"/>
+          <p:cNvSpPr/>
+          <p:nvPr/>
+        </p:nvSpPr>
+        <p:spPr>
+          <a:xfrm>
+            <a:off x="10104120" y="4279320"/>
+            <a:ext cx="1993392" cy="655200"/>
+          </a:xfrm>
+          <a:prstGeom prst="roundRect">
+            <a:avLst>
+              <a:gd name="adj" fmla="val 16667"/>
+            </a:avLst>
+          </a:prstGeom>
+          <a:solidFill>
+            <a:srgbClr val="E8ECF0"/>
+          </a:solidFill>
+          <a:ln w="12700">
+            <a:solidFill>
+              <a:srgbClr val="909AA8"/>
+            </a:solidFill>
+            <a:round/>
+          </a:ln>
+          <a:effectLst>
+            <a:outerShdw blurRad="39960" dir="5400000" dist="23040" rotWithShape="0">
+              <a:srgbClr val="000000">
+                <a:alpha val="35000"/>
+              </a:srgbClr>
+            </a:outerShdw>
+          </a:effectLst>
+        </p:spPr>
+        <p:style>
+          <a:lnRef idx="1">
+            <a:schemeClr val="accent1"/>
+          </a:lnRef>
+          <a:fillRef idx="3">
+            <a:schemeClr val="accent1"/>
+          </a:fillRef>
+          <a:effectRef idx="2">
+            <a:schemeClr val="accent1"/>
+          </a:effectRef>
+          <a:fontRef idx="minor"/>
+        </p:style>
+        <p:txBody>
+          <a:bodyPr lIns="73080" tIns="54720" rIns="73080" bIns="54720" anchor="ctr">
+            <a:noAutofit/>
+          </a:bodyPr>
+          <a:p>
+            <a:pPr algn="ctr" defTabSz="457200">
+              <a:lnSpc>
+                <a:spcPct val="100000"/>
+              </a:lnSpc>
+            </a:pPr>
+            <a:r>
+              <a:rPr lang="en-US" sz="1200" b="0" u="none" strike="noStrike">
+                <a:solidFill>
+                  <a:srgbClr val="1A1A2E"/>
+                </a:solidFill>
+                <a:effectLst/>
+                <a:uFillTx/>
+                <a:latin typeface="Calibri"/>
+              </a:rPr>
+              <a:t>9.5/10†</a:t>
+            </a:r>
+            <a:endParaRPr lang="en-US" sz="1200" b="0" u="none" strike="noStrike">
+              <a:solidFill>
+                <a:srgbClr val="000000"/>
+              </a:solidFill>
+              <a:effectLst/>
+              <a:uFillTx/>
+              <a:latin typeface="Arial"/>
+            </a:endParaRPr>
+          </a:p>
+        </p:txBody>
+      </p:sp>
+      <p:sp>
+        <p:nvSpPr>
+          <p:cNvPr id="169" name="Rounded Rectangle 36"/>
+          <p:cNvSpPr/>
+          <p:nvPr/>
+        </p:nvSpPr>
+        <p:spPr>
+          <a:xfrm>
+            <a:off x="10104120" y="5029200"/>
+            <a:ext cx="1993392" cy="655200"/>
+          </a:xfrm>
+          <a:prstGeom prst="roundRect">
+            <a:avLst>
+              <a:gd name="adj" fmla="val 16667"/>
+            </a:avLst>
+          </a:prstGeom>
+          <a:solidFill>
+            <a:srgbClr val="FFFFFF"/>
+          </a:solidFill>
+          <a:ln w="12700">
+            <a:solidFill>
+              <a:srgbClr val="909AA8"/>
+            </a:solidFill>
+            <a:round/>
+          </a:ln>
+          <a:effectLst>
+            <a:outerShdw blurRad="39960" dir="5400000" dist="23040" rotWithShape="0">
+              <a:srgbClr val="000000">
+                <a:alpha val="35000"/>
+              </a:srgbClr>
+            </a:outerShdw>
+          </a:effectLst>
+        </p:spPr>
+        <p:style>
+          <a:lnRef idx="1">
+            <a:schemeClr val="accent1"/>
+          </a:lnRef>
+          <a:fillRef idx="3">
+            <a:schemeClr val="accent1"/>
+          </a:fillRef>
+          <a:effectRef idx="2">
+            <a:schemeClr val="accent1"/>
+          </a:effectRef>
+          <a:fontRef idx="minor"/>
+        </p:style>
+        <p:txBody>
+          <a:bodyPr lIns="73080" tIns="54720" rIns="73080" bIns="54720" anchor="ctr">
+            <a:noAutofit/>
+          </a:bodyPr>
+          <a:p>
+            <a:pPr algn="ctr" defTabSz="457200">
+              <a:lnSpc>
+                <a:spcPct val="100000"/>
+              </a:lnSpc>
+            </a:pPr>
+            <a:r>
+              <a:rPr lang="en-US" sz="1200" b="0" u="none" strike="noStrike">
+                <a:solidFill>
+                  <a:srgbClr val="1A1A2E"/>
+                </a:solidFill>
+                <a:effectLst/>
+                <a:uFillTx/>
+                <a:latin typeface="Calibri"/>
+              </a:rPr>
+              <a:t>Dev-familiar</a:t>
+            </a:r>
+            <a:endParaRPr lang="en-US" sz="1200" b="0" u="none" strike="noStrike">
+              <a:solidFill>
+                <a:srgbClr val="000000"/>
               </a:solidFill>
               <a:effectLst/>
               <a:uFillTx/>

</xml_diff>